<commit_message>
Improved topic 1 and added topic themes for easier referencing
</commit_message>
<xml_diff>
--- a/World Cafe Facilitation Guide/Source/Station Topics.pptx
+++ b/World Cafe Facilitation Guide/Source/Station Topics.pptx
@@ -1849,7 +1849,7 @@
                 <a:ea typeface="IBM Plex Mono" pitchFamily="34" charset="-122"/>
                 <a:cs typeface="IBM Plex Mono" pitchFamily="34" charset="-120"/>
               </a:rPr>
-              <a:t>THE HUMAN-CENTERED PICTURE</a:t>
+              <a:t>WHAT HUMAN-CENTERED AI LOOKS LIKE</a:t>
             </a:r>
             <a:endParaRPr lang="en-US" sz="1200" dirty="0"/>
           </a:p>
@@ -1891,7 +1891,7 @@
                 <a:ea typeface="Sora" pitchFamily="34" charset="-122"/>
                 <a:cs typeface="Sora" pitchFamily="34" charset="-120"/>
               </a:rPr>
-              <a:t>What should human-centered AI look like in your organization? What results or outcomes would you see? What do you hear people say or ask regarding AI?</a:t>
+              <a:t>What should human-centered AI look like in your organization? What results or outcomes would you see?</a:t>
             </a:r>
             <a:endParaRPr lang="en-US" sz="2700" dirty="0"/>
           </a:p>
@@ -2667,7 +2667,7 @@
                 <a:ea typeface="IBM Plex Mono" pitchFamily="34" charset="-122"/>
                 <a:cs typeface="IBM Plex Mono" pitchFamily="34" charset="-120"/>
               </a:rPr>
-              <a:t>WHEN AI SUPPORTED PEOPLE</a:t>
+              <a:t>WHEN AI HELPS</a:t>
             </a:r>
             <a:endParaRPr lang="en-US" sz="1200" dirty="0"/>
           </a:p>
@@ -3485,7 +3485,7 @@
                 <a:ea typeface="IBM Plex Mono" pitchFamily="34" charset="-122"/>
                 <a:cs typeface="IBM Plex Mono" pitchFamily="34" charset="-120"/>
               </a:rPr>
-              <a:t>WHERE IT SLID OFF COURSE</a:t>
+              <a:t>WHEN AI GETS IN THE WAY </a:t>
             </a:r>
             <a:endParaRPr lang="en-US" sz="1200" dirty="0"/>
           </a:p>
@@ -4303,7 +4303,7 @@
                 <a:ea typeface="IBM Plex Mono" pitchFamily="34" charset="-122"/>
                 <a:cs typeface="IBM Plex Mono" pitchFamily="34" charset="-120"/>
               </a:rPr>
-              <a:t>RULES &amp; PROCESSES TO PUT IN PLACE</a:t>
+              <a:t>RULES &amp; PROCESSES</a:t>
             </a:r>
             <a:endParaRPr lang="en-US" sz="1200" dirty="0"/>
           </a:p>
@@ -5121,7 +5121,7 @@
                 <a:ea typeface="IBM Plex Mono" pitchFamily="34" charset="-122"/>
                 <a:cs typeface="IBM Plex Mono" pitchFamily="34" charset="-120"/>
               </a:rPr>
-              <a:t>WHAT TO MEASURE &amp; AUDIT</a:t>
+              <a:t>MEASUREMENT &amp; AUDITING</a:t>
             </a:r>
             <a:endParaRPr lang="en-US" sz="1200" dirty="0"/>
           </a:p>

</xml_diff>